<commit_message>
Apresentação A10: portfólio em dois slides e fechamento
O portfólio deixa a fila de 7 molduras pequenas e passa a ocupar dois
slides com molduras de 390x487px (4:5): 03 com Cape Town, Holmes
Residence, Solenne e Pátio Estaleiro; 04 com Aurora, Diamond Hill e
Florence Garden mais a faixa de investimento.

Novo slide 06 de fechamento: "Vamos conversar?" com três campos
tracejados a preencher — telefone/WhatsApp, Instagram e site — no mesmo
tratamento do campo de faixa de investimento.

Deck vai a 6 slides; paginação, PDF, PPTX e README acompanham.

Co-Authored-By: Claude Opus 5 <noreply@anthropic.com>
Claude-Session: https://claude.ai/code/session_01TJa9R7UxP8zrdjFY8Jr1NQ
</commit_message>
<xml_diff>
--- a/A10_PADRAO/saidas/Institucional_A10/apresentacao/A10_Apresentacao_Institucional.pptx
+++ b/A10_PADRAO/saidas/Institucional_A10/apresentacao/A10_Apresentacao_Institucional.pptx
@@ -9,6 +9,8 @@
     <p:sldId id="257" r:id="rId8"/>
     <p:sldId id="258" r:id="rId9"/>
     <p:sldId id="259" r:id="rId10"/>
+    <p:sldId id="260" r:id="rId11"/>
+    <p:sldId id="261" r:id="rId12"/>
   </p:sldIdLst>
   <p:sldSz cx="12191695" cy="6858000" type="screen4x3"/>
   <p:notesSz cx="6858000" cy="9144000"/>
@@ -3177,7 +3179,7 @@
       <p:grpSpPr/>
       <p:pic>
         <p:nvPicPr>
-          <p:cNvPr id="2" name="Picture 1" descr="A10_Apresentacao_03_Portfolio_1920x1080_preview.png"/>
+          <p:cNvPr id="2" name="Picture 1" descr="A10_Apresentacao_03_Portfolio_1de2_1920x1080_preview.png"/>
           <p:cNvPicPr>
             <a:picLocks noChangeAspect="1"/>
           </p:cNvPicPr>
@@ -3219,7 +3221,91 @@
       <p:grpSpPr/>
       <p:pic>
         <p:nvPicPr>
-          <p:cNvPr id="2" name="Picture 1" descr="A10_Apresentacao_04_PrimeiroContato_1920x1080_preview.png"/>
+          <p:cNvPr id="2" name="Picture 1" descr="A10_Apresentacao_04_Portfolio_2de2_1920x1080_preview.png"/>
+          <p:cNvPicPr>
+            <a:picLocks noChangeAspect="1"/>
+          </p:cNvPicPr>
+          <p:nvPr/>
+        </p:nvPicPr>
+        <p:blipFill>
+          <a:blip r:embed="rId2"/>
+          <a:stretch>
+            <a:fillRect/>
+          </a:stretch>
+        </p:blipFill>
+        <p:spPr>
+          <a:xfrm>
+            <a:off x="0" y="0"/>
+            <a:ext cx="12191695" cy="6858000"/>
+          </a:xfrm>
+          <a:prstGeom prst="rect">
+            <a:avLst/>
+          </a:prstGeom>
+        </p:spPr>
+      </p:pic>
+    </p:spTree>
+  </p:cSld>
+  <p:clrMapOvr>
+    <a:masterClrMapping/>
+  </p:clrMapOvr>
+</p:sld>
+</file>
+
+<file path=ppt/slides/slide5.xml><?xml version="1.0" encoding="utf-8"?>
+<p:sld xmlns:a="http://schemas.openxmlformats.org/drawingml/2006/main" xmlns:p="http://schemas.openxmlformats.org/presentationml/2006/main" xmlns:r="http://schemas.openxmlformats.org/officeDocument/2006/relationships">
+  <p:cSld>
+    <p:spTree>
+      <p:nvGrpSpPr>
+        <p:cNvPr id="1" name=""/>
+        <p:cNvGrpSpPr/>
+        <p:nvPr/>
+      </p:nvGrpSpPr>
+      <p:grpSpPr/>
+      <p:pic>
+        <p:nvPicPr>
+          <p:cNvPr id="2" name="Picture 1" descr="A10_Apresentacao_05_PrimeiroContato_1920x1080_preview.png"/>
+          <p:cNvPicPr>
+            <a:picLocks noChangeAspect="1"/>
+          </p:cNvPicPr>
+          <p:nvPr/>
+        </p:nvPicPr>
+        <p:blipFill>
+          <a:blip r:embed="rId2"/>
+          <a:stretch>
+            <a:fillRect/>
+          </a:stretch>
+        </p:blipFill>
+        <p:spPr>
+          <a:xfrm>
+            <a:off x="0" y="0"/>
+            <a:ext cx="12191695" cy="6858000"/>
+          </a:xfrm>
+          <a:prstGeom prst="rect">
+            <a:avLst/>
+          </a:prstGeom>
+        </p:spPr>
+      </p:pic>
+    </p:spTree>
+  </p:cSld>
+  <p:clrMapOvr>
+    <a:masterClrMapping/>
+  </p:clrMapOvr>
+</p:sld>
+</file>
+
+<file path=ppt/slides/slide6.xml><?xml version="1.0" encoding="utf-8"?>
+<p:sld xmlns:a="http://schemas.openxmlformats.org/drawingml/2006/main" xmlns:p="http://schemas.openxmlformats.org/presentationml/2006/main" xmlns:r="http://schemas.openxmlformats.org/officeDocument/2006/relationships">
+  <p:cSld>
+    <p:spTree>
+      <p:nvGrpSpPr>
+        <p:cNvPr id="1" name=""/>
+        <p:cNvGrpSpPr/>
+        <p:nvPr/>
+      </p:nvGrpSpPr>
+      <p:grpSpPr/>
+      <p:pic>
+        <p:nvPicPr>
+          <p:cNvPr id="2" name="Picture 1" descr="A10_Apresentacao_06_Fechamento_1920x1080_preview.png"/>
           <p:cNvPicPr>
             <a:picLocks noChangeAspect="1"/>
           </p:cNvPicPr>

</xml_diff>